<commit_message>
Semana 8: presentación con primeras fotos reales de Wikimedia Commons
Co-Authored-By: Claude Opus 5.5 <noreply@anthropic.com>
Claude-Session: https://claude.ai/code/session_01XuLJcNgUM3tZLL1ekwQRQZ
</commit_message>
<xml_diff>
--- a/Actividades/Semana8_Presentacion_Canva.pptx
+++ b/Actividades/Semana8_Presentacion_Canva.pptx
@@ -127,19 +127,19 @@
   <p:extLst>
     <p:ext uri="{521415D9-36F7-43E2-AB2F-B90AF26B5E84}">
       <p14:sectionLst xmlns:p14="http://schemas.microsoft.com/office/powerpoint/2010/main">
-        <p14:section name="Introducción" id="{d07dfa9b-9cdc-b18c-483d-019f1cb7bc9d}">
+        <p14:section name="Introducción" id="{65c95814-a9b0-36e7-b838-b4644fa05862}">
           <p14:sldIdLst>
             <p14:sldId id="256"/>
             <p14:sldId id="257"/>
           </p14:sldIdLst>
         </p14:section>
-        <p14:section name="Conceptos" id="{53e6986f-a460-51d0-0d9d-50963e9aa1ab}">
+        <p14:section name="Conceptos" id="{f872ccda-910b-e35a-53db-835ecd5bf053}">
           <p14:sldIdLst>
             <p14:sldId id="258"/>
             <p14:sldId id="259"/>
           </p14:sldIdLst>
         </p14:section>
-        <p14:section name="Caso 1: comunidad rural" id="{1725790c-f86a-9fb8-c45d-fa0b704a59bc}">
+        <p14:section name="Caso 1: comunidad rural" id="{dc758e72-b750-12ef-ec6c-3b1fdccbe55a}">
           <p14:sldIdLst>
             <p14:sldId id="260"/>
             <p14:sldId id="261"/>
@@ -147,7 +147,7 @@
             <p14:sldId id="263"/>
           </p14:sldIdLst>
         </p14:section>
-        <p14:section name="Caso 2: universitarios" id="{52ffc08c-1192-065e-0138-f965e4df2b11}">
+        <p14:section name="Caso 2: universitarios" id="{39c0f57b-ce0f-d1e8-8ed8-db0d90847bdf}">
           <p14:sldIdLst>
             <p14:sldId id="264"/>
             <p14:sldId id="265"/>
@@ -155,7 +155,7 @@
             <p14:sldId id="267"/>
           </p14:sldIdLst>
         </p14:section>
-        <p14:section name="Caso 3: adultos mayores" id="{30d5da78-0487-393a-c6cd-0452a2b1115c}">
+        <p14:section name="Caso 3: adultos mayores" id="{53adc051-d110-3d6d-5503-5b351e7f0fb3}">
           <p14:sldIdLst>
             <p14:sldId id="268"/>
             <p14:sldId id="269"/>
@@ -163,13 +163,13 @@
             <p14:sldId id="271"/>
           </p14:sldIdLst>
         </p14:section>
-        <p14:section name="Beneficios" id="{9f9e3261-d1d8-0026-cf17-9fe2450ab91d}">
+        <p14:section name="Beneficios" id="{a3307442-993e-4b81-9da4-e3a77028d7a3}">
           <p14:sldIdLst>
             <p14:sldId id="272"/>
             <p14:sldId id="273"/>
           </p14:sldIdLst>
         </p14:section>
-        <p14:section name="Cierre" id="{dcb009cf-1091-9163-2664-24ca5dff43b2}">
+        <p14:section name="Cierre" id="{cc02b9ee-84c6-a99c-185b-2438014d56c2}">
           <p14:sldIdLst>
             <p14:sldId id="274"/>
             <p14:sldId id="275"/>
@@ -12275,7 +12275,7 @@
                             <a:srgbClr val="6A1B9A"/>
                           </a:solidFill>
                         </a:rPr>
-                        <a:t>Imágenes y videos</a:t>
+                        <a:t>Imágenes</a:t>
                       </a:r>
                       <a:endParaRPr lang="en-US" sz="1400" dirty="0"/>
                     </a:p>
@@ -12309,7 +12309,7 @@
                             <a:schemeClr val="tx1"/>
                           </a:solidFill>
                         </a:rPr>
-                        <a:t>Bancos de uso libre (Pexels, Pixabay) e íconos de Canva</a:t>
+                        <a:t>Wikimedia Commons, licencias libres (autor y licencia en cada foto)</a:t>
                       </a:r>
                       <a:endParaRPr lang="en-US" sz="1400" dirty="0"/>
                     </a:p>
@@ -13236,12 +13236,20 @@
           </a:p>
         </p:txBody>
       </p:sp>
-      <p:sp>
-        <p:nvSpPr>
-          <p:cNvPr id="16" name="Recuadro de imagen"/>
-          <p:cNvSpPr/>
-          <p:nvPr/>
-        </p:nvSpPr>
+      <p:pic>
+        <p:nvPicPr>
+          <p:cNvPr id="16" name="Image 0" descr="Nurse checks blood pressure">    </p:cNvPr>
+          <p:cNvPicPr>
+            <a:picLocks noChangeAspect="1"/>
+          </p:cNvPicPr>
+          <p:nvPr/>
+        </p:nvPicPr>
+        <p:blipFill>
+          <a:blip r:embed="rId1"/>
+          <a:stretch>
+            <a:fillRect/>
+          </a:stretch>
+        </p:blipFill>
         <p:spPr>
           <a:xfrm>
             <a:off x="6492240" y="1280160"/>
@@ -13250,64 +13258,65 @@
           <a:prstGeom prst="rect">
             <a:avLst/>
           </a:prstGeom>
+        </p:spPr>
+      </p:pic>
+      <p:sp>
+        <p:nvSpPr>
+          <p:cNvPr id="17" name="Shape 14"/>
+          <p:cNvSpPr/>
+          <p:nvPr/>
+        </p:nvSpPr>
+        <p:spPr>
+          <a:xfrm>
+            <a:off x="6492240" y="4261104"/>
+            <a:ext cx="2194560" cy="219456"/>
+          </a:xfrm>
+          <a:prstGeom prst="rect">
+            <a:avLst/>
+          </a:prstGeom>
           <a:solidFill>
-            <a:srgbClr val="F7F7F7"/>
+            <a:srgbClr val="000000">
+              <a:alpha val="55000"/>
+            </a:srgbClr>
           </a:solidFill>
-          <a:ln w="15875">
-            <a:solidFill>
-              <a:srgbClr val="9E9E9E"/>
-            </a:solidFill>
-            <a:prstDash val="dash"/>
-          </a:ln>
-        </p:spPr>
-      </p:sp>
-      <p:sp>
-        <p:nvSpPr>
-          <p:cNvPr id="17" name="Indicación de imagen"/>
-          <p:cNvSpPr txBox="1"/>
-          <p:nvPr/>
-        </p:nvSpPr>
-        <p:spPr>
-          <a:xfrm>
-            <a:off x="6601968" y="1389888"/>
-            <a:ext cx="1975104" cy="2980944"/>
-          </a:xfrm>
-          <a:prstGeom prst="rect">
-            <a:avLst/>
-          </a:prstGeom>
-          <a:noFill/>
-          <a:ln/>
-        </p:spPr>
-        <p:txBody>
-          <a:bodyPr wrap="square" lIns="0" tIns="0" rIns="0" bIns="0" rtlCol="0" anchor="ctr"/>
-          <a:lstStyle/>
-          <a:p>
-            <a:pPr algn="ctr" indent="0" marL="0">
-              <a:buNone/>
-            </a:pPr>
-            <a:r>
-              <a:rPr lang="en-US" sz="1100" b="1" dirty="0">
-                <a:solidFill>
-                  <a:srgbClr val="6A1B9A"/>
-                </a:solidFill>
-              </a:rPr>
-              <a:t>IMAGEN SUGERIDA</a:t>
-            </a:r>
-            <a:endParaRPr lang="en-US" sz="1100" dirty="0"/>
-          </a:p>
-          <a:p>
-            <a:pPr algn="ctr" indent="0" marL="0">
-              <a:buNone/>
-            </a:pPr>
-            <a:r>
-              <a:rPr lang="en-US" sz="1050" dirty="0">
-                <a:solidFill>
-                  <a:srgbClr val="263238"/>
-                </a:solidFill>
-              </a:rPr>
-              <a:t>Íconos de Canva: escudo (primaria), lupa (secundaria) y curita o corazón (terciaria).</a:t>
-            </a:r>
-            <a:endParaRPr lang="en-US" sz="1100" dirty="0"/>
+          <a:ln/>
+        </p:spPr>
+      </p:sp>
+      <p:sp>
+        <p:nvSpPr>
+          <p:cNvPr id="18" name="Text 15"/>
+          <p:cNvSpPr txBox="1"/>
+          <p:nvPr/>
+        </p:nvSpPr>
+        <p:spPr>
+          <a:xfrm>
+            <a:off x="6565392" y="4261104"/>
+            <a:ext cx="2048256" cy="219456"/>
+          </a:xfrm>
+          <a:prstGeom prst="rect">
+            <a:avLst/>
+          </a:prstGeom>
+          <a:noFill/>
+          <a:ln/>
+        </p:spPr>
+        <p:txBody>
+          <a:bodyPr wrap="square" lIns="0" tIns="0" rIns="0" bIns="0" rtlCol="0" anchor="ctr">
+            <a:normAutofit/>
+          </a:bodyPr>
+          <a:lstStyle/>
+          <a:p>
+            <a:pPr indent="0" marL="0">
+              <a:buNone/>
+            </a:pPr>
+            <a:r>
+              <a:rPr lang="en-US" sz="750" dirty="0">
+                <a:solidFill>
+                  <a:srgbClr val="FFFFFF"/>
+                </a:solidFill>
+              </a:rPr>
+              <a:t>Foto: Linda Bartlett (Photographer) · Public domain · Wikimedia Commons</a:t>
+            </a:r>
+            <a:endParaRPr lang="en-US" sz="750" dirty="0"/>
           </a:p>
         </p:txBody>
       </p:sp>
@@ -14931,12 +14940,20 @@
           </a:p>
         </p:txBody>
       </p:sp>
-      <p:sp>
-        <p:nvSpPr>
-          <p:cNvPr id="22" name="Recuadro de imagen"/>
-          <p:cNvSpPr/>
-          <p:nvPr/>
-        </p:nvSpPr>
+      <p:pic>
+        <p:nvPicPr>
+          <p:cNvPr id="22" name="Image 0" descr="Sweet potato farmers in Peru with pesticide sprayers">    </p:cNvPr>
+          <p:cNvPicPr>
+            <a:picLocks noChangeAspect="1"/>
+          </p:cNvPicPr>
+          <p:nvPr/>
+        </p:nvPicPr>
+        <p:blipFill>
+          <a:blip r:embed="rId1"/>
+          <a:stretch>
+            <a:fillRect/>
+          </a:stretch>
+        </p:blipFill>
         <p:spPr>
           <a:xfrm>
             <a:off x="5212080" y="1234440"/>
@@ -14945,64 +14962,65 @@
           <a:prstGeom prst="rect">
             <a:avLst/>
           </a:prstGeom>
+        </p:spPr>
+      </p:pic>
+      <p:sp>
+        <p:nvSpPr>
+          <p:cNvPr id="23" name="Shape 20"/>
+          <p:cNvSpPr/>
+          <p:nvPr/>
+        </p:nvSpPr>
+        <p:spPr>
+          <a:xfrm>
+            <a:off x="5212080" y="4306824"/>
+            <a:ext cx="3474720" cy="219456"/>
+          </a:xfrm>
+          <a:prstGeom prst="rect">
+            <a:avLst/>
+          </a:prstGeom>
           <a:solidFill>
-            <a:srgbClr val="F7F7F7"/>
+            <a:srgbClr val="000000">
+              <a:alpha val="55000"/>
+            </a:srgbClr>
           </a:solidFill>
-          <a:ln w="15875">
-            <a:solidFill>
-              <a:srgbClr val="9E9E9E"/>
-            </a:solidFill>
-            <a:prstDash val="dash"/>
-          </a:ln>
-        </p:spPr>
-      </p:sp>
-      <p:sp>
-        <p:nvSpPr>
-          <p:cNvPr id="23" name="Indicación de imagen"/>
-          <p:cNvSpPr txBox="1"/>
-          <p:nvPr/>
-        </p:nvSpPr>
-        <p:spPr>
-          <a:xfrm>
-            <a:off x="5321808" y="1344168"/>
-            <a:ext cx="3255264" cy="3072384"/>
-          </a:xfrm>
-          <a:prstGeom prst="rect">
-            <a:avLst/>
-          </a:prstGeom>
-          <a:noFill/>
-          <a:ln/>
-        </p:spPr>
-        <p:txBody>
-          <a:bodyPr wrap="square" lIns="0" tIns="0" rIns="0" bIns="0" rtlCol="0" anchor="ctr"/>
-          <a:lstStyle/>
-          <a:p>
-            <a:pPr algn="ctr" indent="0" marL="0">
-              <a:buNone/>
-            </a:pPr>
-            <a:r>
-              <a:rPr lang="en-US" sz="1100" b="1" dirty="0">
-                <a:solidFill>
-                  <a:srgbClr val="6A1B9A"/>
-                </a:solidFill>
-              </a:rPr>
-              <a:t>IMAGEN SUGERIDA</a:t>
-            </a:r>
-            <a:endParaRPr lang="en-US" sz="1100" dirty="0"/>
-          </a:p>
-          <a:p>
-            <a:pPr algn="ctr" indent="0" marL="0">
-              <a:buNone/>
-            </a:pPr>
-            <a:r>
-              <a:rPr lang="en-US" sz="1050" dirty="0">
-                <a:solidFill>
-                  <a:srgbClr val="263238"/>
-                </a:solidFill>
-              </a:rPr>
-              <a:t>Video o foto de una vereda y de un campesino fumigando sin protección (Pexels: “farmer spraying pesticide”, “rural village Colombia”).</a:t>
-            </a:r>
-            <a:endParaRPr lang="en-US" sz="1100" dirty="0"/>
+          <a:ln/>
+        </p:spPr>
+      </p:sp>
+      <p:sp>
+        <p:nvSpPr>
+          <p:cNvPr id="24" name="Text 21"/>
+          <p:cNvSpPr txBox="1"/>
+          <p:nvPr/>
+        </p:nvSpPr>
+        <p:spPr>
+          <a:xfrm>
+            <a:off x="5285232" y="4306824"/>
+            <a:ext cx="3328416" cy="219456"/>
+          </a:xfrm>
+          <a:prstGeom prst="rect">
+            <a:avLst/>
+          </a:prstGeom>
+          <a:noFill/>
+          <a:ln/>
+        </p:spPr>
+        <p:txBody>
+          <a:bodyPr wrap="square" lIns="0" tIns="0" rIns="0" bIns="0" rtlCol="0" anchor="ctr">
+            <a:normAutofit/>
+          </a:bodyPr>
+          <a:lstStyle/>
+          <a:p>
+            <a:pPr indent="0" marL="0">
+              <a:buNone/>
+            </a:pPr>
+            <a:r>
+              <a:rPr lang="en-US" sz="750" dirty="0">
+                <a:solidFill>
+                  <a:srgbClr val="FFFFFF"/>
+                </a:solidFill>
+              </a:rPr>
+              <a:t>Foto: JIRCAS · CC BY 2.0 · Wikimedia Commons</a:t>
+            </a:r>
+            <a:endParaRPr lang="en-US" sz="750" dirty="0"/>
           </a:p>
         </p:txBody>
       </p:sp>
@@ -16039,12 +16057,20 @@
           </a:p>
         </p:txBody>
       </p:sp>
-      <p:sp>
-        <p:nvSpPr>
-          <p:cNvPr id="32" name="Recuadro de imagen"/>
-          <p:cNvSpPr/>
-          <p:nvPr/>
-        </p:nvSpPr>
+      <p:pic>
+        <p:nvPicPr>
+          <p:cNvPr id="32" name="Image 0" descr="A farmer fetching water in a muddy pond to mix spraying chemical (herbicide) 07">    </p:cNvPr>
+          <p:cNvPicPr>
+            <a:picLocks noChangeAspect="1"/>
+          </p:cNvPicPr>
+          <p:nvPr/>
+        </p:nvPicPr>
+        <p:blipFill>
+          <a:blip r:embed="rId1"/>
+          <a:stretch>
+            <a:fillRect/>
+          </a:stretch>
+        </p:blipFill>
         <p:spPr>
           <a:xfrm>
             <a:off x="6217920" y="1280160"/>
@@ -16053,64 +16079,65 @@
           <a:prstGeom prst="rect">
             <a:avLst/>
           </a:prstGeom>
+        </p:spPr>
+      </p:pic>
+      <p:sp>
+        <p:nvSpPr>
+          <p:cNvPr id="33" name="Shape 30"/>
+          <p:cNvSpPr/>
+          <p:nvPr/>
+        </p:nvSpPr>
+        <p:spPr>
+          <a:xfrm>
+            <a:off x="6217920" y="4352544"/>
+            <a:ext cx="2468880" cy="219456"/>
+          </a:xfrm>
+          <a:prstGeom prst="rect">
+            <a:avLst/>
+          </a:prstGeom>
           <a:solidFill>
-            <a:srgbClr val="F7F7F7"/>
+            <a:srgbClr val="000000">
+              <a:alpha val="55000"/>
+            </a:srgbClr>
           </a:solidFill>
-          <a:ln w="15875">
-            <a:solidFill>
-              <a:srgbClr val="9E9E9E"/>
-            </a:solidFill>
-            <a:prstDash val="dash"/>
-          </a:ln>
-        </p:spPr>
-      </p:sp>
-      <p:sp>
-        <p:nvSpPr>
-          <p:cNvPr id="33" name="Indicación de imagen"/>
-          <p:cNvSpPr txBox="1"/>
-          <p:nvPr/>
-        </p:nvSpPr>
-        <p:spPr>
-          <a:xfrm>
-            <a:off x="6327648" y="1389888"/>
-            <a:ext cx="2249424" cy="3072384"/>
-          </a:xfrm>
-          <a:prstGeom prst="rect">
-            <a:avLst/>
-          </a:prstGeom>
-          <a:noFill/>
-          <a:ln/>
-        </p:spPr>
-        <p:txBody>
-          <a:bodyPr wrap="square" lIns="0" tIns="0" rIns="0" bIns="0" rtlCol="0" anchor="ctr"/>
-          <a:lstStyle/>
-          <a:p>
-            <a:pPr algn="ctr" indent="0" marL="0">
-              <a:buNone/>
-            </a:pPr>
-            <a:r>
-              <a:rPr lang="en-US" sz="1100" b="1" dirty="0">
-                <a:solidFill>
-                  <a:srgbClr val="6A1B9A"/>
-                </a:solidFill>
-              </a:rPr>
-              <a:t>IMAGEN SUGERIDA</a:t>
-            </a:r>
-            <a:endParaRPr lang="en-US" sz="1100" dirty="0"/>
-          </a:p>
-          <a:p>
-            <a:pPr algn="ctr" indent="0" marL="0">
-              <a:buNone/>
-            </a:pPr>
-            <a:r>
-              <a:rPr lang="en-US" sz="1050" dirty="0">
-                <a:solidFill>
-                  <a:srgbClr val="263238"/>
-                </a:solidFill>
-              </a:rPr>
-              <a:t>Íconos de Canva para cada riesgo, o una foto relacionada con el riesgo principal.</a:t>
-            </a:r>
-            <a:endParaRPr lang="en-US" sz="1100" dirty="0"/>
+          <a:ln/>
+        </p:spPr>
+      </p:sp>
+      <p:sp>
+        <p:nvSpPr>
+          <p:cNvPr id="34" name="Text 31"/>
+          <p:cNvSpPr txBox="1"/>
+          <p:nvPr/>
+        </p:nvSpPr>
+        <p:spPr>
+          <a:xfrm>
+            <a:off x="6291072" y="4352544"/>
+            <a:ext cx="2322576" cy="219456"/>
+          </a:xfrm>
+          <a:prstGeom prst="rect">
+            <a:avLst/>
+          </a:prstGeom>
+          <a:noFill/>
+          <a:ln/>
+        </p:spPr>
+        <p:txBody>
+          <a:bodyPr wrap="square" lIns="0" tIns="0" rIns="0" bIns="0" rtlCol="0" anchor="ctr">
+            <a:normAutofit/>
+          </a:bodyPr>
+          <a:lstStyle/>
+          <a:p>
+            <a:pPr indent="0" marL="0">
+              <a:buNone/>
+            </a:pPr>
+            <a:r>
+              <a:rPr lang="en-US" sz="750" dirty="0">
+                <a:solidFill>
+                  <a:srgbClr val="FFFFFF"/>
+                </a:solidFill>
+              </a:rPr>
+              <a:t>Foto: Danjuma Anthony · CC BY-SA 4.0 · Wikimedia Commons</a:t>
+            </a:r>
+            <a:endParaRPr lang="en-US" sz="750" dirty="0"/>
           </a:p>
         </p:txBody>
       </p:sp>

</xml_diff>

<commit_message>
Semana 8: fotos del campesino y la estudiante en la introducción
Co-Authored-By: Claude Opus 5.5 <noreply@anthropic.com>
Claude-Session: https://claude.ai/code/session_01XuLJcNgUM3tZLL1ekwQRQZ
</commit_message>
<xml_diff>
--- a/Actividades/Semana8_Presentacion_Canva.pptx
+++ b/Actividades/Semana8_Presentacion_Canva.pptx
@@ -127,19 +127,19 @@
   <p:extLst>
     <p:ext uri="{521415D9-36F7-43E2-AB2F-B90AF26B5E84}">
       <p14:sectionLst xmlns:p14="http://schemas.microsoft.com/office/powerpoint/2010/main">
-        <p14:section name="Introducción" id="{65c95814-a9b0-36e7-b838-b4644fa05862}">
+        <p14:section name="Introducción" id="{c1e835f4-f160-8f35-4a3a-567e432c7c6f}">
           <p14:sldIdLst>
             <p14:sldId id="256"/>
             <p14:sldId id="257"/>
           </p14:sldIdLst>
         </p14:section>
-        <p14:section name="Conceptos" id="{f872ccda-910b-e35a-53db-835ecd5bf053}">
+        <p14:section name="Conceptos" id="{e0112d95-aae3-1f66-07a9-ef0291964ce4}">
           <p14:sldIdLst>
             <p14:sldId id="258"/>
             <p14:sldId id="259"/>
           </p14:sldIdLst>
         </p14:section>
-        <p14:section name="Caso 1: comunidad rural" id="{dc758e72-b750-12ef-ec6c-3b1fdccbe55a}">
+        <p14:section name="Caso 1: comunidad rural" id="{0a0bb942-57bd-622e-088e-ffe77938e320}">
           <p14:sldIdLst>
             <p14:sldId id="260"/>
             <p14:sldId id="261"/>
@@ -147,7 +147,7 @@
             <p14:sldId id="263"/>
           </p14:sldIdLst>
         </p14:section>
-        <p14:section name="Caso 2: universitarios" id="{39c0f57b-ce0f-d1e8-8ed8-db0d90847bdf}">
+        <p14:section name="Caso 2: universitarios" id="{ada13d92-a209-27c8-6bb3-fa3549576ef0}">
           <p14:sldIdLst>
             <p14:sldId id="264"/>
             <p14:sldId id="265"/>
@@ -155,7 +155,7 @@
             <p14:sldId id="267"/>
           </p14:sldIdLst>
         </p14:section>
-        <p14:section name="Caso 3: adultos mayores" id="{53adc051-d110-3d6d-5503-5b351e7f0fb3}">
+        <p14:section name="Caso 3: adultos mayores" id="{892f8ea0-cc14-9e5a-4048-bdcca8076689}">
           <p14:sldIdLst>
             <p14:sldId id="268"/>
             <p14:sldId id="269"/>
@@ -163,13 +163,13 @@
             <p14:sldId id="271"/>
           </p14:sldIdLst>
         </p14:section>
-        <p14:section name="Beneficios" id="{a3307442-993e-4b81-9da4-e3a77028d7a3}">
+        <p14:section name="Beneficios" id="{48de8ad5-bfa1-b27a-ab40-58fac2dca9e4}">
           <p14:sldIdLst>
             <p14:sldId id="272"/>
             <p14:sldId id="273"/>
           </p14:sldIdLst>
         </p14:section>
-        <p14:section name="Cierre" id="{cc02b9ee-84c6-a99c-185b-2438014d56c2}">
+        <p14:section name="Cierre" id="{dd415784-fc7e-b80f-144c-1dec6d906d4e}">
           <p14:sldIdLst>
             <p14:sldId id="274"/>
             <p14:sldId id="275"/>
@@ -11502,16 +11502,184 @@
           </a:p>
         </p:txBody>
       </p:sp>
-      <p:sp>
-        <p:nvSpPr>
-          <p:cNvPr id="15" name="Recuadro de imagen"/>
+      <p:pic>
+        <p:nvPicPr>
+          <p:cNvPr id="15" name="Image 0" descr="Campesino colombiano y su ganado">    </p:cNvPr>
+          <p:cNvPicPr>
+            <a:picLocks noChangeAspect="1"/>
+          </p:cNvPicPr>
+          <p:nvPr/>
+        </p:nvPicPr>
+        <p:blipFill>
+          <a:blip r:embed="rId1"/>
+          <a:stretch>
+            <a:fillRect/>
+          </a:stretch>
+        </p:blipFill>
+        <p:spPr>
+          <a:xfrm>
+            <a:off x="5852160" y="3063240"/>
+            <a:ext cx="914400" cy="1463040"/>
+          </a:xfrm>
+          <a:prstGeom prst="rect">
+            <a:avLst/>
+          </a:prstGeom>
+        </p:spPr>
+      </p:pic>
+      <p:sp>
+        <p:nvSpPr>
+          <p:cNvPr id="16" name="Shape 13"/>
           <p:cNvSpPr/>
           <p:nvPr/>
         </p:nvSpPr>
         <p:spPr>
           <a:xfrm>
-            <a:off x="5852160" y="3063240"/>
-            <a:ext cx="2834640" cy="1463040"/>
+            <a:off x="5852160" y="4306824"/>
+            <a:ext cx="914400" cy="219456"/>
+          </a:xfrm>
+          <a:prstGeom prst="rect">
+            <a:avLst/>
+          </a:prstGeom>
+          <a:solidFill>
+            <a:srgbClr val="000000">
+              <a:alpha val="55000"/>
+            </a:srgbClr>
+          </a:solidFill>
+          <a:ln/>
+        </p:spPr>
+      </p:sp>
+      <p:sp>
+        <p:nvSpPr>
+          <p:cNvPr id="17" name="Text 14"/>
+          <p:cNvSpPr txBox="1"/>
+          <p:nvPr/>
+        </p:nvSpPr>
+        <p:spPr>
+          <a:xfrm>
+            <a:off x="5925312" y="4306824"/>
+            <a:ext cx="768096" cy="219456"/>
+          </a:xfrm>
+          <a:prstGeom prst="rect">
+            <a:avLst/>
+          </a:prstGeom>
+          <a:noFill/>
+          <a:ln/>
+        </p:spPr>
+        <p:txBody>
+          <a:bodyPr wrap="square" lIns="0" tIns="0" rIns="0" bIns="0" rtlCol="0" anchor="ctr">
+            <a:normAutofit/>
+          </a:bodyPr>
+          <a:lstStyle/>
+          <a:p>
+            <a:pPr indent="0" marL="0">
+              <a:buNone/>
+            </a:pPr>
+            <a:r>
+              <a:rPr lang="en-US" sz="750" dirty="0">
+                <a:solidFill>
+                  <a:srgbClr val="FFFFFF"/>
+                </a:solidFill>
+              </a:rPr>
+              <a:t>Foto: Julianruizp · CC BY-SA 4.0 · Wikimedia Commons</a:t>
+            </a:r>
+            <a:endParaRPr lang="en-US" sz="750" dirty="0"/>
+          </a:p>
+        </p:txBody>
+      </p:sp>
+      <p:pic>
+        <p:nvPicPr>
+          <p:cNvPr id="18" name="Image 1" descr="Sias Library - Students Studying 2017">    </p:cNvPr>
+          <p:cNvPicPr>
+            <a:picLocks noChangeAspect="1"/>
+          </p:cNvPicPr>
+          <p:nvPr/>
+        </p:nvPicPr>
+        <p:blipFill>
+          <a:blip r:embed="rId2"/>
+          <a:stretch>
+            <a:fillRect/>
+          </a:stretch>
+        </p:blipFill>
+        <p:spPr>
+          <a:xfrm>
+            <a:off x="6812280" y="3063240"/>
+            <a:ext cx="914400" cy="1463040"/>
+          </a:xfrm>
+          <a:prstGeom prst="rect">
+            <a:avLst/>
+          </a:prstGeom>
+        </p:spPr>
+      </p:pic>
+      <p:sp>
+        <p:nvSpPr>
+          <p:cNvPr id="19" name="Shape 15"/>
+          <p:cNvSpPr/>
+          <p:nvPr/>
+        </p:nvSpPr>
+        <p:spPr>
+          <a:xfrm>
+            <a:off x="6812280" y="4306824"/>
+            <a:ext cx="914400" cy="219456"/>
+          </a:xfrm>
+          <a:prstGeom prst="rect">
+            <a:avLst/>
+          </a:prstGeom>
+          <a:solidFill>
+            <a:srgbClr val="000000">
+              <a:alpha val="55000"/>
+            </a:srgbClr>
+          </a:solidFill>
+          <a:ln/>
+        </p:spPr>
+      </p:sp>
+      <p:sp>
+        <p:nvSpPr>
+          <p:cNvPr id="20" name="Text 16"/>
+          <p:cNvSpPr txBox="1"/>
+          <p:nvPr/>
+        </p:nvSpPr>
+        <p:spPr>
+          <a:xfrm>
+            <a:off x="6885432" y="4306824"/>
+            <a:ext cx="768096" cy="219456"/>
+          </a:xfrm>
+          <a:prstGeom prst="rect">
+            <a:avLst/>
+          </a:prstGeom>
+          <a:noFill/>
+          <a:ln/>
+        </p:spPr>
+        <p:txBody>
+          <a:bodyPr wrap="square" lIns="0" tIns="0" rIns="0" bIns="0" rtlCol="0" anchor="ctr">
+            <a:normAutofit/>
+          </a:bodyPr>
+          <a:lstStyle/>
+          <a:p>
+            <a:pPr indent="0" marL="0">
+              <a:buNone/>
+            </a:pPr>
+            <a:r>
+              <a:rPr lang="en-US" sz="750" dirty="0">
+                <a:solidFill>
+                  <a:srgbClr val="FFFFFF"/>
+                </a:solidFill>
+              </a:rPr>
+              <a:t>Foto: Gary Todd · CC0 · Wikimedia Commons</a:t>
+            </a:r>
+            <a:endParaRPr lang="en-US" sz="750" dirty="0"/>
+          </a:p>
+        </p:txBody>
+      </p:sp>
+      <p:sp>
+        <p:nvSpPr>
+          <p:cNvPr id="21" name="Recuadro de imagen"/>
+          <p:cNvSpPr/>
+          <p:nvPr/>
+        </p:nvSpPr>
+        <p:spPr>
+          <a:xfrm>
+            <a:off x="7772400" y="3063240"/>
+            <a:ext cx="914400" cy="1463040"/>
           </a:xfrm>
           <a:prstGeom prst="rect">
             <a:avLst/>
@@ -11529,14 +11697,14 @@
       </p:sp>
       <p:sp>
         <p:nvSpPr>
-          <p:cNvPr id="16" name="Indicación de imagen"/>
-          <p:cNvSpPr txBox="1"/>
-          <p:nvPr/>
-        </p:nvSpPr>
-        <p:spPr>
-          <a:xfrm>
-            <a:off x="5961888" y="3172968"/>
-            <a:ext cx="2615184" cy="1243584"/>
+          <p:cNvPr id="22" name="Indicación de imagen"/>
+          <p:cNvSpPr txBox="1"/>
+          <p:nvPr/>
+        </p:nvSpPr>
+        <p:spPr>
+          <a:xfrm>
+            <a:off x="7882128" y="3172968"/>
+            <a:ext cx="694944" cy="1243584"/>
           </a:xfrm>
           <a:prstGeom prst="rect">
             <a:avLst/>
@@ -11571,7 +11739,7 @@
                   <a:srgbClr val="263238"/>
                 </a:solidFill>
               </a:rPr>
-              <a:t>Collage de tres fotos: campesino, estudiante y adulto mayor (Pexels: “farmer”, “university student”, “elderly”).</a:t>
+              <a:t>Adulto mayor (Pexels: “elderly”)</a:t>
             </a:r>
             <a:endParaRPr lang="en-US" sz="1100" dirty="0"/>
           </a:p>

</xml_diff>

<commit_message>
Semana 8: guion corregido (población dirigida, concordancia, normas con número, beneficios por niveles y nuevo cierre); música resincronizada a 7:50
Co-Authored-By: Claude Opus 5.5 <noreply@anthropic.com>
Claude-Session: https://claude.ai/code/session_01XuLJcNgUM3tZLL1ekwQRQZ
</commit_message>
<xml_diff>
--- a/Actividades/Semana8_Presentacion_Canva.pptx
+++ b/Actividades/Semana8_Presentacion_Canva.pptx
@@ -130,19 +130,19 @@
   <p:extLst>
     <p:ext uri="{521415D9-36F7-43E2-AB2F-B90AF26B5E84}">
       <p14:sectionLst xmlns:p14="http://schemas.microsoft.com/office/powerpoint/2010/main">
-        <p14:section name="Introducción" id="{de108cc6-857a-53f7-1a4c-6af9bf52eb3a}">
+        <p14:section name="Introducción" id="{055fdf2d-c020-b12c-90c1-66984da50c75}">
           <p14:sldIdLst>
             <p14:sldId id="256"/>
             <p14:sldId id="257"/>
           </p14:sldIdLst>
         </p14:section>
-        <p14:section name="Conceptos" id="{b6172d22-9d9e-468b-373e-c5b59c5f4172}">
+        <p14:section name="Conceptos" id="{ca7e3031-7e8e-d8b5-ee17-5a2bca33c220}">
           <p14:sldIdLst>
             <p14:sldId id="258"/>
             <p14:sldId id="259"/>
           </p14:sldIdLst>
         </p14:section>
-        <p14:section name="Caso 1: comunidad rural" id="{df6d97db-37d2-72d8-9721-5e28df5bccc9}">
+        <p14:section name="Caso 1: comunidad rural" id="{6d7cb8e3-81e0-be40-5eed-03f08ed62238}">
           <p14:sldIdLst>
             <p14:sldId id="260"/>
             <p14:sldId id="261"/>
@@ -151,7 +151,7 @@
             <p14:sldId id="264"/>
           </p14:sldIdLst>
         </p14:section>
-        <p14:section name="Caso 2: universitarios" id="{38c2834f-2b7c-32bb-5b08-845d2af3ced2}">
+        <p14:section name="Caso 2: universitarios" id="{2f2c67bf-6aae-84ad-79b7-6e56b4435187}">
           <p14:sldIdLst>
             <p14:sldId id="265"/>
             <p14:sldId id="266"/>
@@ -160,7 +160,7 @@
             <p14:sldId id="269"/>
           </p14:sldIdLst>
         </p14:section>
-        <p14:section name="Caso 3: adultos mayores" id="{247c9fca-4f77-b832-06c1-ea9b2de8d7a9}">
+        <p14:section name="Caso 3: adultos mayores" id="{cb697ed0-5ad6-76c8-5321-2af237e0b4c3}">
           <p14:sldIdLst>
             <p14:sldId id="270"/>
             <p14:sldId id="271"/>
@@ -169,13 +169,13 @@
             <p14:sldId id="274"/>
           </p14:sldIdLst>
         </p14:section>
-        <p14:section name="Beneficios" id="{6badf3b3-713d-d347-9007-23a54b454afa}">
+        <p14:section name="Beneficios" id="{4e9e93df-50f0-daaf-b92a-a3ac9c427eab}">
           <p14:sldIdLst>
             <p14:sldId id="275"/>
             <p14:sldId id="276"/>
           </p14:sldIdLst>
         </p14:section>
-        <p14:section name="Cierre" id="{23b6877d-be52-1425-e63d-1b0a74388e9d}">
+        <p14:section name="Cierre" id="{5db9e599-29a1-3ee8-d3c9-02f7e34acfdc}">
           <p14:sldIdLst>
             <p14:sldId id="277"/>
             <p14:sldId id="278"/>
@@ -677,10 +677,10 @@
           <a:p>
             <a:r>
               <a:rPr lang="en-US" dirty="0"/>
-              <a:t>Escena 10. Caso 2: población y necesidades (2:55 – 3:20, 25 s)
+              <a:t>Escena 10. Caso 2: población y necesidades (3:00 – 3:25, 25 s)
 Música: Dinámica y juvenil
 VOZ EN OFF:
-El segundo caso son estudiantes universitarios de 18 a 25 años que vienen de otras regiones y viven en residencias o viviendas compartidas. En salud, no tienen hábitos de autocuidado; en nutrición, comen comida rápida y toman mucho café y bebidas energéticas; en su entorno, pasan horas frente a pantallas; y en prevención, se mueven poco y duermen mal.</a:t>
+El segundo caso es el de estudiantes universitarios de 18 a 25 años que vienen de otras regiones y viven en residencias o viviendas compartidas. En salud, no tienen hábitos de autocuidado; en nutrición, comen comida rápida y toman mucho café y bebidas energéticas; en su entorno, pasan horas frente a pantallas; y en prevención, se mueven poco y duermen mal.</a:t>
             </a:r>
             <a:endParaRPr lang="en-US" dirty="0"/>
           </a:p>
@@ -768,7 +768,7 @@
           <a:p>
             <a:r>
               <a:rPr lang="en-US" dirty="0"/>
-              <a:t>Escena 11. Caso 2: riesgos (3:20 – 3:40, 20 s)
+              <a:t>Escena 11. Caso 2: riesgos (3:25 – 3:45, 20 s)
 Música: Dinámica y juvenil
 VOZ EN OFF:
 Esto genera sobrepeso, sedentarismo, problemas posturales, ansiedad, insomnio y, con los años, riesgo cardiovascular. Es un riesgo por estilos de vida y psicosocial; es individual, pero se repite en muchos estudiantes. Por eso su prioridad es media-alta.</a:t>
@@ -859,7 +859,7 @@
           <a:p>
             <a:r>
               <a:rPr lang="en-US" dirty="0"/>
-              <a:t>Escena 12. Caso 2: la actividad (3:40 – 4:00, 20 s)
+              <a:t>Escena 12. Caso 2: la actividad (3:45 – 4:05, 20 s)
 Música: Dinámica y juvenil
 VOZ EN OFF:
 Propongo la campaña “Recarga tu bienestar”, de prevención primaria y secundaria. Busca que los estudiantes cuiden su alimentación, su actividad física, su descanso y su salud mental. Lo innovador es que la feria se hace antes de los parciales y continúa con retos en redes sociales.</a:t>
@@ -950,7 +950,7 @@
           <a:p>
             <a:r>
               <a:rPr lang="en-US" dirty="0"/>
-              <a:t>Escena 13. Caso 2: ¿cómo se hace? (4:00 – 4:20, 20 s)
+              <a:t>Escena 13. Caso 2: ¿cómo se hace? (4:05 – 4:25, 20 s)
 Música: Dinámica y juvenil
 VOZ EN OFF:
 La feria tiene tres estaciones: tamizaje, comida rápida pero sana, y muévete y desconéctate. La atienden enfermería, nutrición, psicología y deporte, con Bienestar Universitario y la EPS. Quien tenga un riesgo se remite a atención, y se mide cuántos estudiantes fueron tamizados.</a:t>
@@ -1041,10 +1041,10 @@
           <a:p>
             <a:r>
               <a:rPr lang="en-US" dirty="0"/>
-              <a:t>Escena 14. Caso 2: respaldo normativo y viabilidad (4:20 – 4:40, 20 s)
+              <a:t>Escena 14. Caso 2: respaldo normativo y viabilidad (4:25 – 4:45, 20 s)
 Música: Dinámica y juvenil
 VOZ EN OFF:
-La respaldan la Resolución 3280 en el momento de juventud, las leyes de obesidad y de etiquetado frontal, la Ley de salud mental y el Decreto 729 de 2025. Es viable porque Bienestar Universitario tiene presupuesto propio; el reto es lograr que los estudiantes participen.</a:t>
+La respaldan la Resolución 3280, en la juventud; las leyes 1355, de obesidad, y 2120, de etiquetado frontal; y el Decreto 729 de 2025, de salud mental. Es viable con el presupuesto de Bienestar Universitario; el reto es lograr que los estudiantes participen.</a:t>
             </a:r>
             <a:endParaRPr lang="en-US" dirty="0"/>
           </a:p>
@@ -1132,10 +1132,10 @@
           <a:p>
             <a:r>
               <a:rPr lang="en-US" dirty="0"/>
-              <a:t>Escena 15. Caso 3: población y necesidades (4:40 – 5:05, 25 s)
+              <a:t>Escena 15. Caso 3: población y necesidades (4:45 – 5:10, 25 s)
 Música: Cálida (piano)
 VOZ EN OFF:
-El tercer caso son adultos mayores de un barrio periférico, con bajos ingresos, y muchos viven solos. En salud, tienen hipertensión y diabetes y no siguen bien sus tratamientos; en nutrición, comen poca proteína, fruta y verdura; en su entorno, las casas tienen pisos resbalosos y poca luz; y en prevención, casi no asisten a los encuentros comunitarios.</a:t>
+El tercer caso es el de adultos mayores de un barrio periférico, con bajos ingresos; muchos viven solos. En salud, tienen hipertensión y diabetes y no siguen bien sus tratamientos; en nutrición, comen poca proteína, fruta y verdura; en su entorno, las casas tienen pisos resbalosos y poca luz; y en prevención, casi no asisten a los encuentros comunitarios.</a:t>
             </a:r>
             <a:endParaRPr lang="en-US" dirty="0"/>
           </a:p>
@@ -1223,7 +1223,7 @@
           <a:p>
             <a:r>
               <a:rPr lang="en-US" dirty="0"/>
-              <a:t>Escena 16. Caso 3: riesgos (5:05 – 5:25, 20 s)
+              <a:t>Escena 16. Caso 3: riesgos (5:10 – 5:30, 20 s)
 Música: Cálida (piano)
 VOZ EN OFF:
 Los riesgos son las complicaciones de la hipertensión y la diabetes, la pérdida de masa muscular, las caídas y la soledad. Es un riesgo cardiovascular, de caídas y psicosocial. Su prioridad es alta, porque una caída o un infarto pueden quitarle la autonomía a quien vive solo.</a:t>
@@ -1314,7 +1314,7 @@
           <a:p>
             <a:r>
               <a:rPr lang="en-US" dirty="0"/>
-              <a:t>Escena 17. Caso 3: la actividad (5:25 – 5:45, 20 s)
+              <a:t>Escena 17. Caso 3: la actividad (5:30 – 5:50, 20 s)
 Música: Cálida (piano)
 VOZ EN OFF:
 Propongo el club “Envejecer con salud”, de prevención secundaria y terciaria, para personas de 60 años o más y sus cuidadores. Su objetivo es controlar las enfermedades crónicas, prevenir caídas y reducir la soledad. Lo innovador es el “vecino acompañante” y que los mayores enseñan sus oficios.</a:t>
@@ -1405,7 +1405,7 @@
           <a:p>
             <a:r>
               <a:rPr lang="en-US" dirty="0"/>
-              <a:t>Escena 18. Caso 3: ¿cómo se hace? (5:45 – 6:05, 20 s)
+              <a:t>Escena 18. Caso 3: ¿cómo se hace? (5:50 – 6:10, 20 s)
 Música: Cálida (piano)
 VOZ EN OFF:
 Cada semana se toma la presión y la glucosa, se hacen ejercicios de fuerza y equilibrio y talleres de alimentación económica. Además, se visitan las casas para revisar riesgos de caídas. Participan enfermería, medicina, nutrición y trabajo social, con el Centro Vida, la ESE y la EPS.</a:t>
@@ -1496,7 +1496,7 @@
           <a:p>
             <a:r>
               <a:rPr lang="en-US" dirty="0"/>
-              <a:t>Escena 19. Caso 3: respaldo normativo y viabilidad (6:05 – 6:25, 20 s)
+              <a:t>Escena 19. Caso 3: respaldo normativo y viabilidad (6:10 – 6:30, 20 s)
 Música: Cálida (piano)
 VOZ EN OFF:
 La respaldan la Resolución 3280 en el momento de vejez, la Ley 1251, la Ley 1276, que crea los Centros Vida, y el Decreto 681 de 2022. Se financia con la estampilla del adulto mayor; el reto es llegar a quienes no pueden salir de casa.</a:t>
@@ -1587,10 +1587,10 @@
           <a:p>
             <a:r>
               <a:rPr lang="en-US" dirty="0"/>
-              <a:t>Escena 2. Introducción (0:10 – 0:30, 20 s)
+              <a:t>Escena 2. Introducción (0:10 – 0:35, 25 s)
 Música: Suave
 VOZ EN OFF:
-Hola, soy Yina Vanessa Cadena Mantilla, estudiante de la Especialización en Gerencia y Auditoría de la Calidad en Salud de UNIMINUTO. En este video presento tres propuestas de prevención para una comunidad rural agrícola, estudiantes universitarios y adultos mayores de un barrio periférico.</a:t>
+Hola, soy Yina Vanessa Cadena Mantilla, estudiante de la Especialización en Gerencia y Auditoría de la Calidad en Salud de UNIMINUTO. Este video está dirigido a la comunidad y a los equipos de salud, y presenta propuestas de prevención para una comunidad rural, estudiantes universitarios y adultos mayores.</a:t>
             </a:r>
             <a:endParaRPr lang="en-US" dirty="0"/>
           </a:p>
@@ -1678,10 +1678,10 @@
           <a:p>
             <a:r>
               <a:rPr lang="en-US" dirty="0"/>
-              <a:t>Escena 20. Beneficios para todos (6:25 – 6:45, 20 s)
+              <a:t>Escena 20. Beneficios para todos (6:30 – 6:50, 20 s)
 Música: Suave
 VOZ EN OFF:
-¿Cuáles son los beneficios para todos? Prevenir significa menos enfermedades, menos gastos y más calidad de vida. Tratar tarde significa hospitalizaciones, complicaciones, gasto de bolsillo y pérdida de autonomía. Prevenir siempre cuesta menos que tratar una enfermedad avanzada.</a:t>
+¿Cuáles son los beneficios para todos? Las personas viven más años con salud y autonomía; las familias gastan menos y tienen menos enfermos que cuidar; y el sistema ahorra hospitalizaciones y tratamientos costosos. Prevenir siempre cuesta menos que tratar una enfermedad avanzada.</a:t>
             </a:r>
             <a:endParaRPr lang="en-US" dirty="0"/>
           </a:p>
@@ -1769,7 +1769,7 @@
           <a:p>
             <a:r>
               <a:rPr lang="en-US" dirty="0"/>
-              <a:t>Escena 21. Beneficios del sistema (6:45 – 7:05, 20 s)
+              <a:t>Escena 21. Beneficios del sistema (6:50 – 7:10, 20 s)
 Música: Suave
 VOZ EN OFF:
 Además, el sistema de salud colombiano garantiza la Ruta de Promoción y Mantenimiento, servicios de promoción y prevención sin copagos ni cuotas moderadoras, acciones gratuitas del Plan de Intervenciones Colectivas y vacunación gratuita para toda la población.</a:t>
@@ -1860,10 +1860,10 @@
           <a:p>
             <a:r>
               <a:rPr lang="en-US" dirty="0"/>
-              <a:t>Escena 22. Cierre (7:05 – 7:25, 20 s)
+              <a:t>Escena 22. Cierre (7:10 – 7:30, 20 s)
 Música: Cálida, en crescendo
 VOZ EN OFF:
-Cada población necesita una respuesta distinta. Cuando la comunidad, el sistema de salud y el Estado trabajan juntos, la prevención llega a donde vive la gente. Prevenir es cuidar, y cuidar es tarea de todos. Gracias.</a:t>
+Prevenir no es esperar a que llegue la enfermedad, es adelantarse a ella. Con acciones sencillas, cercanas y pensadas para cada población, es posible ganar años de vida con salud. Gracias por acompañarme.</a:t>
             </a:r>
             <a:endParaRPr lang="en-US" dirty="0"/>
           </a:p>
@@ -1951,7 +1951,7 @@
           <a:p>
             <a:r>
               <a:rPr lang="en-US" dirty="0"/>
-              <a:t>Escena 23. Referencias (7:25 – 7:35, 10 s)
+              <a:t>Escena 23. Referencias (7:30 – 7:40, 10 s)
 Música: Suave
 VOZ EN OFF:
 (Sin voz.)</a:t>
@@ -2042,7 +2042,7 @@
           <a:p>
             <a:r>
               <a:rPr lang="en-US" dirty="0"/>
-              <a:t>Escena 24. Créditos (7:35 – 7:45, 10 s)
+              <a:t>Escena 24. Créditos (7:40 – 7:50, 10 s)
 Música: Se desvanece
 VOZ EN OFF:
 (Sin voz.)</a:t>
@@ -2133,7 +2133,7 @@
           <a:p>
             <a:r>
               <a:rPr lang="en-US" dirty="0"/>
-              <a:t>Escena 3. Niveles de prevención (0:30 – 0:50, 20 s)
+              <a:t>Escena 3. Niveles de prevención (0:35 – 0:55, 20 s)
 Música: Suave
 VOZ EN OFF:
 Promover la salud es dar a las personas herramientas para cuidarse. La prevención tiene tres niveles: la primaria evita que la enfermedad aparezca; la secundaria la detecta a tiempo, con tamizajes y controles; y la terciaria evita complicaciones en quien ya está enfermo.</a:t>
@@ -2224,10 +2224,10 @@
           <a:p>
             <a:r>
               <a:rPr lang="en-US" dirty="0"/>
-              <a:t>Escena 4. Marco normativo (0:50 – 1:10, 20 s)
+              <a:t>Escena 4. Marco normativo (0:55 – 1:15, 20 s)
 Música: Suave
 VOZ EN OFF:
-Estas propuestas se apoyan en normas vigentes: la Ley 1751 de 2015 reconoce la salud como derecho fundamental; la Resolución 3280 de 2018 adopta la Ruta de Promoción y Mantenimiento; y la Resolución 1597 de 2025 regula hoy el Plan de Intervenciones Colectivas.</a:t>
+Estas propuestas no parten de cero: la Ley 1751 de 2015 reconoce la salud como un derecho fundamental; la Resolución 3280 de 2018 crea la Ruta de Promoción y Mantenimiento de la Salud; y la Resolución 1597 de 2025 define el Plan de Intervenciones Colectivas.</a:t>
             </a:r>
             <a:endParaRPr lang="en-US" dirty="0"/>
           </a:p>
@@ -2315,7 +2315,7 @@
           <a:p>
             <a:r>
               <a:rPr lang="en-US" dirty="0"/>
-              <a:t>Escena 5. Caso 1: población y necesidades (1:10 – 1:35, 25 s)
+              <a:t>Escena 5. Caso 1: población y necesidades (1:15 – 1:40, 25 s)
 Música: Acústica de campo
 VOZ EN OFF:
 El primer caso es una vereda agrícola, con familias campesinas de varias generaciones: adultos de 30 a 50 años y niños que acompañan las labores del campo. En salud, consultan poco de forma preventiva; en nutrición, manipulan los alimentos sin higiene; en su entorno, el agua no se trata y las letrinas son improvisadas; y en prevención, fumigan sin protección.</a:t>
@@ -2406,7 +2406,7 @@
           <a:p>
             <a:r>
               <a:rPr lang="en-US" dirty="0"/>
-              <a:t>Escena 6. Caso 1: riesgos (1:35 – 1:55, 20 s)
+              <a:t>Escena 6. Caso 1: riesgos (1:40 – 2:00, 20 s)
 Música: Acústica de campo
 VOZ EN OFF:
 Por eso aparecen intoxicaciones leves, enfermedades de la piel y respiratorias, diarrea en los niños y lesiones articulares. Es un riesgo ambiental y ocupacional, de tipo colectivo, porque toda la vereda comparte la misma agua y la misma exposición. Su prioridad es alta.</a:t>
@@ -2497,7 +2497,7 @@
           <a:p>
             <a:r>
               <a:rPr lang="en-US" dirty="0"/>
-              <a:t>Escena 7. Caso 1: la actividad (1:55 – 2:15, 20 s)
+              <a:t>Escena 7. Caso 1: la actividad (2:00 – 2:20, 20 s)
 Música: Acústica de campo
 VOZ EN OFF:
 Propongo la jornada “Finca sana, familia sana”, de prevención primaria. Su objetivo es reducir la exposición al agua no segura y a los agroquímicos. Lo novedoso es que se hace en la misma vereda, sin interrumpir el trabajo, y con juegos entre madres e hijos.</a:t>
@@ -2588,7 +2588,7 @@
           <a:p>
             <a:r>
               <a:rPr lang="en-US" dirty="0"/>
-              <a:t>Escena 8. Caso 1: ¿cómo se hace? (2:15 – 2:35, 20 s)
+              <a:t>Escena 8. Caso 1: ¿cómo se hace? (2:20 – 2:40, 20 s)
 Música: Acústica de campo
 VOZ EN OFF:
 La jornada tiene tres estaciones: agua segura, agroquímicos sin riesgo y cuerpo sano. La atienden el técnico de saneamiento, enfermería y un promotor de salud, junto con la Secretaría de Salud, la ESE, la UMATA y la escuela. Se mide cuántos hogares tratan el agua.</a:t>
@@ -2679,10 +2679,10 @@
           <a:p>
             <a:r>
               <a:rPr lang="en-US" dirty="0"/>
-              <a:t>Escena 9. Caso 1: respaldo normativo y viabilidad (2:35 – 2:55, 20 s)
+              <a:t>Escena 9. Caso 1: respaldo normativo y viabilidad (2:40 – 3:00, 20 s)
 Música: Acústica de campo
 VOZ EN OFF:
-Se financia con el Plan de Intervenciones Colectivas y se apoya en el Código Sanitario y en las normas de calidad del agua. Es viable porque es de bajo costo, pero tiene un reto: la Secretaría de Salud debe incluirla en su plan territorial para que haya recursos.</a:t>
+Se financia con el Plan de Intervenciones Colectivas y se apoya en la Ley 9 de 1979 y en la Resolución 2115 de 2007, sobre calidad del agua. Es de bajo costo, pero tiene un reto: la Secretaría de Salud debe incluirla en su plan territorial.</a:t>
             </a:r>
             <a:endParaRPr lang="en-US" dirty="0"/>
           </a:p>
@@ -15422,7 +15422,7 @@
                   <a:schemeClr val="bg1"/>
                 </a:solidFill>
               </a:rPr>
-              <a:t>Prevenir es cuidar, y cuidar es tarea de todos</a:t>
+              <a:t>Adelantarse a la enfermedad también es cuidar</a:t>
             </a:r>
             <a:endParaRPr lang="en-US" sz="3400" dirty="0"/>
           </a:p>
@@ -15458,7 +15458,7 @@
                   <a:srgbClr val="E1BEE7"/>
                 </a:solidFill>
               </a:rPr>
-              <a:t>Cada población necesita una respuesta distinta. Cuando la comunidad, el sistema de salud y el Estado trabajan juntos, la prevención llega a donde vive la gente.</a:t>
+              <a:t>Prevenir no es esperar a que llegue la enfermedad. Con acciones sencillas, cercanas y pensadas para cada población, es posible ganar años de vida con salud.</a:t>
             </a:r>
             <a:endParaRPr lang="en-US" sz="1600" dirty="0"/>
           </a:p>

</xml_diff>